<commit_message>
Correct management pack approval wording
</commit_message>
<xml_diff>
--- a/tentativedemodocs/DWI-Prompt-Optimizer-Management-Demo.pptx
+++ b/tentativedemodocs/DWI-Prompt-Optimizer-Management-Demo.pptx
@@ -1227,13 +1227,12 @@
             <a:r>
               <a:rPr lang="en-US" dirty="0"/>
               <a:t>Ask management to evaluate usefulness and support a staged learning plan, not to declare production readiness.
-The sponsor estimates that the consolidated product and report make a focused management proof of concept possible in roughly four days rather than restarting a four-month discovery exercise. This is a planning estimate, not a production-delivery promise.
-The sequence is simple: run the management POC, audit every pivotal decision, build an approval-led policy mechanism, prove it in dry-run mode, and only then consider a separately authorized comparison or pilot.
+The sequence is simple: review the current product and evidence, audit every pivotal decision, build an approval-led policy mechanism, prove it in dry-run mode, and only then consider a separately authorized comparison or pilot.
 The structured workflow and engineering controls passed locally and in exact-commit GitHub CI.
-Phase 4 exposed a clear governance failure. The owner approved calls, no retries and monetary ceilings; the contract prepared by the AI assistant added token ceilings without explicit owner approval, and the 12,000 ceiling became decisive.
+Phase 4 exposed a clear governance failure. The human approver approved calls, no retries and monetary ceilings; the contract prepared by the AI assistant added token ceilings without explicit approval from the human approver, and the 12,000 ceiling became decisive.
 The token check happened after the response, so it could stop later calls but not the first call’s use. The dollar ceilings were recorded, but available pricing and billing data could not enforce or prove actual cost.
 The fail-closed stop and evidence preservation worked. Phase 4 remains deliberately frozen, and quality remains unmeasured because no business task or quality comparison ran.
-The future mechanism must be imperative in decision: verify owner approval and rule provenance, calculate an adaptive allowance from approved inputs, explain it, and stop before an external call when authority is missing.</a:t>
+The future mechanism must be imperative in decision: verify approval from the human approver and rule provenance, calculate an adaptive allowance from approved inputs, explain it, and stop before an external call when authority is missing.</a:t>
             </a:r>
             <a:endParaRPr lang="en-US" dirty="0"/>
           </a:p>
@@ -8399,7 +8398,7 @@
                 <a:ea typeface="Aptos" pitchFamily="34" charset="-122"/>
                 <a:cs typeface="Aptos" pitchFamily="34" charset="-120"/>
               </a:rPr>
-              <a:t>Owner-approved inputs, calculation and hard limits</a:t>
+              <a:t>Inputs confirmed by the human approver, calculation and hard limits</a:t>
             </a:r>
             <a:endParaRPr lang="en-US" sz="1080" dirty="0"/>
           </a:p>
@@ -10988,7 +10987,7 @@
                 <a:ea typeface="Aptos" pitchFamily="34" charset="-122"/>
                 <a:cs typeface="Aptos" pitchFamily="34" charset="-120"/>
               </a:rPr>
-              <a:t>POC</a:t>
+              <a:t>TODAY</a:t>
             </a:r>
             <a:endParaRPr lang="en-US" sz="880" dirty="0"/>
           </a:p>
@@ -11029,7 +11028,7 @@
                 <a:ea typeface="Aptos" pitchFamily="34" charset="-122"/>
                 <a:cs typeface="Aptos" pitchFamily="34" charset="-120"/>
               </a:rPr>
-              <a:t>Four-day management POC</a:t>
+              <a:t>Try the current demo</a:t>
             </a:r>
             <a:endParaRPr lang="en-US" sz="1650" dirty="0"/>
           </a:p>
@@ -11070,7 +11069,7 @@
                 <a:ea typeface="Aptos" pitchFamily="34" charset="-122"/>
                 <a:cs typeface="Aptos" pitchFamily="34" charset="-120"/>
               </a:rPr>
-              <a:t>Planning target—not a delivery promise; use the current product instead of restarting four months of discovery.</a:t>
+              <a:t>Use representative work and assess clarity, reuse and developer control.</a:t>
             </a:r>
             <a:endParaRPr lang="en-US" sz="1180" dirty="0"/>
           </a:p>
@@ -11704,7 +11703,7 @@
                 <a:ea typeface="Aptos" pitchFamily="34" charset="-122"/>
                 <a:cs typeface="Aptos" pitchFamily="34" charset="-120"/>
               </a:rPr>
-              <a:t>Should management authorize the four-day POC and decision audit before Phase 4 resumes?</a:t>
+              <a:t>Does the value demonstrated by the current workflow justify a small, controlled dry-run of the future model?</a:t>
             </a:r>
             <a:endParaRPr lang="en-US" sz="1860" dirty="0"/>
           </a:p>

</xml_diff>